<commit_message>
Simplify demos into five before-and-after workflow pairs
Keep only the DXC presentation deck and ten self-contained manual workflows. Embed updated presenter scripts, setup, comparison cues, and cleanup in the deck while preserving the 50-minute presentation and 10-minute Q&A schedule.

Co-authored-by: Copilot App <223556219+Copilot@users.noreply.github.com>
</commit_message>
<xml_diff>
--- a/outputs/slides/dxc-actions-office-hour-2026-10-13.pptx
+++ b/outputs/slides/dxc-actions-office-hour-2026-10-13.pptx
@@ -792,7 +792,7 @@
           <a:lstStyle/>
           <a:p>
             <a:r>
-              <a:t>Welcome to our October GitHub Actions Office Hour. Today we are focusing on five updates selected for their practical impact on DXC delivery: cache access controls, workflow execution protections, expired artifact visibility, bounded workflow reporting, and self-hosted runner enforcement. Our research window is September 10 through October 9, 2026. We will distinguish new capabilities from operational changes, and distinguish published behavior from what we actually observe in our demo repository. The first fifty minutes are for the presentation and demonstrations. At minute fifty we will stop and reserve the final ten minutes for questions. Everything demonstrated is designed to run from a GitHub repository using Actions workflows. We will not modify production runner fleets or apply organization-wide policies as part of this session.</a:t>
+              <a:t>Welcome to our October GitHub Actions Office Hour. Today we will walk through five selected updates using a simple before-and-after comparison for each one. The topics are cache permissions, workflow execution protections, expired artifact visibility, bounded reporting, and runner readiness. The repository now contains just this presentation and ten self-contained workflow files. Each pair is numbered so we can open Before, run it, and then open After to see the change. The Before examples show older configuration patterns or assumptions on today's GitHub service; they do not bring retired service behavior back. All speaking notes and setup instructions are embedded in this deck. We will use fifty minutes for the presentation and demos and preserve the final ten minutes for questions. No demo changes a production runner fleet.</a:t>
             </a:r>
           </a:p>
         </p:txBody>
@@ -862,7 +862,7 @@
           <a:lstStyle/>
           <a:p>
             <a:r>
-              <a:t>The September twenty-fourth update removes expired artifacts from the workflow run summary and the REST API. Previously the interface could retain an expired entry even after the artifact files were already deleted. That made it easy to confuse a visible record with actual retained content, and it created ambiguity around storage billing. The update removes that stale visibility. It does not change retention settings or billing rules. Integrations therefore need to handle a record being absent rather than depending on an expired flag remaining in a list. The original run logs can still show what the workflow produced while those logs are themselves retained. Our demonstration separates the artifact from a longer-lived receipt so we can inspect disappearance against its original identity and expiry time.</a:t>
+              <a:t>The September twenty-fourth release removes expired artifacts from the Actions run summary and REST API. Previously an expired pill could remain after the files had gone. We cannot switch today's service back to that older display behavior. Instead, our Before workflow creates a real artifact and records its identity while it exists. Our After workflow observes the same artifact after natural expiry and service cleanup. That is a genuine lifecycle demonstration of the new visibility behavior, not a simulated old interface. The feature changes display and API visibility, not the artifact retention setting or billing rules. Retained logs can still show the original upload while those logs remain available. Our separate fourteen-day receipt lets us compare the original artifact identity and expiry with its later absence.</a:t>
             </a:r>
           </a:p>
         </p:txBody>
@@ -932,7 +932,7 @@
           <a:lstStyle/>
           <a:p>
             <a:r>
-              <a:t>We cannot faithfully accelerate a day-based retention policy into a few minutes by deleting the artifact ourselves. The seed workflow must run before delivery. It uploads a one-day artifact and reads its actual identity and expiration from GitHub. It then stores a separate receipt for fourteen days. On inspection, we verify that the selected seed run succeeded and that the original expiry has passed. Only then do we check the run artifact list and direct artifact endpoint. If the artifact remains visible while cleanup is pending, the workflow reports not ready and fails explicitly. We also have to be precise about attribution: absence alone cannot prove natural expiry rather than manual deletion. In this prepared demo we intentionally do not delete the target, and we retain the original upload logs and receipt as provenance.</a:t>
+              <a:t>This comparison has one unavoidable preparation step: time. Run Demo 3 BEFORE at least a day before you want to demonstrate After. The Before summary shows the original artifact ID and the actual expires_at returned by GitHub. It also retains a small receipt artifact for fourteen days. Copy the successful Before run ID. After the original expiry has passed and GitHub has cleaned up the target, run Demo 3 AFTER with that ID. The After workflow downloads the receipt, validates it against the selected run, and checks both list visibility and the direct artifact endpoint. It reports an error if the expiry has not passed or the artifact remains visible. Do not delete the target to manufacture the result. Absence alone cannot distinguish deletion from natural expiry; the preserved receipt and our no-deletion procedure provide the provenance.</a:t>
             </a:r>
           </a:p>
         </p:txBody>
@@ -1002,7 +1002,7 @@
           <a:lstStyle/>
           <a:p>
             <a:r>
-              <a:t>Open the earlier seed run first, not a new run. Point out the target artifact's original ID, creation time, and expiry, and the separately retained receipt. Launch inspect mode using that seed run ID or open the completed inspection rehearsal. Show the inspector's two observations: the target is absent from the run artifact list, and the direct GET returns 404. Keep the receipt and original upload step nearby so the audience can connect absence to a known artifact. State that no manual deletion occurred and that the result is consistent with natural expiry. If the seed has not expired or service cleanup is incomplete, the correct result is not ready; do not change timestamps or delete the artifact to manufacture a success. Connect the outcome to DXC delivery integrations: handle absent records and plan evidence retention explicitly, without inferring billing changes from UI behavior.</a:t>
+              <a:t>Open the completed Demo 3 BEFORE run prepared earlier. Say: This artifact genuinely existed, and here is GitHub's original expiration time. Show the small retained receipt and original upload step, then copy the Before run ID. Select Demo 3 AFTER and enter that ID. Open its completed summary to compare the absent target in the run artifact list with the direct GET returning 404. Say: The files and stale entry are gone, but our retained receipt still identifies what existed. This is not a billing change. If After says not ready, the target has not expired or cleanup is incomplete; wait or show an identified earlier rehearsal. A 403 or credential error is not evidence of expiry. If the receipt is missing, verify the run ID and whether its fourteen-day retention has passed. Transition: Next, we will compare a broad first-page report with a date-bounded, paginated query.</a:t>
             </a:r>
           </a:p>
         </p:txBody>
@@ -1072,7 +1072,7 @@
           <a:lstStyle/>
           <a:p>
             <a:r>
-              <a:t>The reporting update addresses broad queries that previously timed out and could return misleading counts. The announcement says that counts beyond two thousand five hundred are reported as two thousand five hundred plus instead of an attempted exact count. Separately, a filtered workflow-run search still returns up to one thousand items. Those are different limits. A bounded count is not an exact activity total, and requesting more pages does not overcome the filtered retrieval cap. Also, the REST schema and the UI label need not have identical representations. Our client examines the actual returned value instead of blindly requiring the UI's string format. In a small repository we will demonstrate the query pattern and pagination, but we will not claim to have observed the large-volume threshold.</a:t>
+              <a:t>Keep these two limits separate. The announcement describes a bounded count label above two thousand five hundred matching runs. Independently, a filtered workflow-run query can return only up to one thousand records. One returned page is not a complete export, and pagination cannot remove that filtered retrieval cap. Our Before example deliberately fetches only two records from one broad page and labels the result incomplete. After adds an explicit UTC day, follows pages, and refuses a query whose count reaches the cap or is not an exact below-cap number. This simplified version asks us to narrow the time window rather than implementing recursive splitting. We will inspect actual API values. A small repository does not demonstrate the two-thousand-five-hundred-plus threshold, and there are no synthetic fixture results being presented as live data.</a:t>
             </a:r>
           </a:p>
         </p:txBody>
@@ -1142,7 +1142,7 @@
           <a:lstStyle/>
           <a:p>
             <a:r>
-              <a:t>The client queries a specific UTC time window and looks at the returned count before trying to enumerate it. If the count is bounded or reaches the one-thousand-item filtered cap, it divides the window into adjacent ranges with no gaps or overlap. Smaller windows can then be paginated, and the collected run IDs are deduplicated. A request budget and a smallest-window guard prevent unbounded API traffic or silent truncation. If the result cannot be enumerated safely, the script fails rather than writing a success-shaped complete report. This is still not an atomic snapshot: creation or deletion during the requests can change what the API returns.</a:t>
+              <a:t>The After example is deliberately short. It asks for a valid UTC date, reads that day's reported count, and refuses a saturated or non-exact result. It then uses the GitHub CLI's pagination support and displays distinct run IDs in the job summary. If the chosen day has too many runs, stop and narrow to a smaller time interval in the API query; do not label a capped export complete. This is a practical comparison of an incomplete first-page approach with a better bounded query, not a production reporting framework. Concurrent changes can still affect the returned results because the API is not an atomic snapshot. If there are no runs for the selected UTC date, choose the day on which the rehearsal workflows actually ran.</a:t>
             </a:r>
           </a:p>
         </p:txBody>
@@ -1212,7 +1212,7 @@
           <a:lstStyle/>
           <a:p>
             <a:r>
-              <a:t>Run the reporting workflow with dates that cover our rehearsal runs and page size two. This makes ordinary pagination visible without generating thousands of workflows. Open its summary and JSON to show the actual returned counts, distinct run IDs, and request count. Point to the explicit statement about whether a count requiring splitting was observed. If it says false, state clearly that we did not observe the large-volume threshold in this repository. Then show the unit test that feeds a synthetic bounded-count response to the splitting algorithm. Identify this as an offline fixture, not a real GitHub response. It proves the client's branch behavior and adjacent-window calculation, while a genuine threshold observation would require an approved high-volume repository. For production, use page size one hundred and a sensible date range.</a:t>
+              <a:t>Select Demo 4 BEFORE and run it. Open the summary to show the two returned records next to GitHub's reported total_count. Say: Fetching one page is not the same as retrieving every matching run. Next open Demo 4 AFTER. Enter the UTC date containing the rehearsal runs; the default is the October thirteenth session date, so change it if rehearsing on a different day. The After job uses a date filter, follows pages, and shows distinct run IDs. Say: We have improved the query scope and pagination without building a complicated reporting system. If the query reaches one thousand records or the returned count is bounded, it stops visibly and asks us to narrow the window. With our small demo repository, do not claim to have observed the two-thousand-five-hundred threshold. This example is live query handling on the current API, not a replay of the old service. Transition: Our last pair compares a registration-only assumption with separate live support dates.</a:t>
             </a:r>
           </a:p>
         </p:txBody>
@@ -1352,7 +1352,7 @@
           <a:lstStyle/>
           <a:p>
             <a:r>
-              <a:t>Open the runner-readiness workflow. Use repository scope and the default explicit versions unless an organization inventory was approved and rehearsed. The job runs on a hosted runner and only performs read operations against the administrative endpoint. Show registration and runtime dates in separate columns. Explain that a null date is reported as no date returned, not as a supported-version guarantee. If we enable inventory, visible runner versions are added to the lookups and missing versions remain an explicit data-quality issue. The audit does not register, stop, downgrade, upgrade, or delete runners. If administrator access is unavailable, state that the live endpoint is blocked and use a clearly identified rehearsal or the API shape rather than fabricated dates. Keep the demo brief and move to the adoption checklist at minute forty-five.</a:t>
+              <a:t>Open Demo 5 BEFORE and use version two-point-three-two-nine-zero. The job makes a simple local numeric comparison with the announced registration minimum. Say: This result is only a registration-floor comparison. It is not a real registration attempt and it tells us nothing conclusive about job-runtime support. Then run Demo 5 AFTER for the same version. Before rehearsal, create a demo-admin environment restricted to the default branch and store an approved RUNNER_READ_TOKEN with repository Administration read access; the identity must have administrator access where the endpoint requires it. Missing access produces an explicit error. After reads GitHub's registration and runtime deprecation dates separately and marks returned deadlines as passed or upcoming. A null date stays unknown, not green. No runner fleet is touched. If administrator access is unavailable, explain that the live lookup is blocked and show an identified rehearsal rather than inventing dates. Move to the adoption checklist at minute forty-five.</a:t>
             </a:r>
           </a:p>
         </p:txBody>
@@ -1422,7 +1422,7 @@
           <a:lstStyle/>
           <a:p>
             <a:r>
-              <a:t>These are the five practical follow-through actions I recommend. CI maintainers should map cache access to job trust rather than applying write everywhere. Platform governance should pilot file-scoped execution protections, using evaluate where available and reviewing real enforcement evidence before broad rollout. Delivery integration owners should make missing expired artifacts a normal handled case and retain provenance where the delivery process needs it. Reporting engineers should inspect actual count values, split time windows before retrieval caps, and avoid treating a truncated query as a complete activity total. Runner operations should audit both registration and runtime dates, keeping unknown versions visible. These are recommended owner roles, not assignments to specific DXC individuals. Start narrowly and review account policies, credentials, and evidence before scaling.</a:t>
+              <a:t>Here are five straightforward adoption actions based on the comparisons we just saw. CI maintainers should choose explicit cache access rather than granting write everywhere. Platform governance should pilot a file-scoped policy and confirm an actual pre-job block, not confuse a workflow's own failure with central enforcement. Delivery integration owners should handle expired artifacts being absent and retain provenance when required. Reporting engineers should bound time windows, follow pages, and stop when the filtered retrieval cap prevents a complete answer. Runner operations should inspect registration and runtime support separately. The repository's ten files are intentionally small teaching examples, not a new platform framework. Extend them only after reviewing the account's policies, permissions, and production needs. These are suggested owner roles, not assignments to specific DXC individuals.</a:t>
             </a:r>
           </a:p>
         </p:txBody>
@@ -1492,7 +1492,7 @@
           <a:lstStyle/>
           <a:p>
             <a:r>
-              <a:t>Our shared theme is to control execution while preserving the meaning of the evidence we collect. Cache permissions and workflow policies address different layers of least privilege. Artifact visibility and bounded counts remind us that a record's absence or a returned count must be interpreted carefully. Runner readiness requires separate registration and runtime checks. Keep the demo patterns narrow, credentials scoped, and cleanup explicit. One relevant upcoming date is November second, when the announced default pull_request_target policy is enforced for affected public repositories; that is not a claim of universal enforcement today. We have reached the fifty-minute handoff, so I will stop starting demonstrations here. If a workflow is still queued, it can finish independently without consuming the question period. Let's use the final ten minutes for the scenarios and adoption concerns most relevant to your teams.</a:t>
+              <a:t>The takeaway is intentionally simple: make the access boundary explicit, inspect the actual evidence, and separate a convenient assumption from a verified operational result. We now have ten small before-and-after workflows that can be opened and run independently from GitHub, with no repository helper scripts. For policy enforcement we still need the central setting, and for artifact expiry we still need real elapsed time. Those are inherent feature prerequisites, not complexity we can legitimately script away. Keep the demo patterns narrow and credentials scoped. The announced default pull_request_target protection on affected public repositories is enforced on November second; that is not universal active enforcement today. We have reached the fifty-minute handoff. Stop starting demonstrations and reserve the full final ten minutes for questions.</a:t>
             </a:r>
           </a:p>
         </p:txBody>
@@ -1562,7 +1562,7 @@
           <a:lstStyle/>
           <a:p>
             <a:r>
-              <a:t>Here is the run of show. Following the title and agenda, cache controls start at minute three and get the first deep dive, followed by execution protections. We then move from security to operational evidence: artifact expiry and reporting limits. We finish the technical content with a read-only runner readiness audit. The final five minutes before Q&amp;A are for an actionable adoption checklist and any short runner-queue buffer. The demo budgets are presenter budgets, not a promise that GitHub will provision every hosted runner instantly. I will use rehearsed runs if a live queue threatens the schedule. That keeps the full ten-minute question period intact.</a:t>
+              <a:t>Following the title and agenda, we start the cache comparison at minute three. Each selected feature has two small workflows: Before and After. We will read the short YAML, run it from the Actions tab, and use the job summary or policy result as our visual evidence. Execution protections follow cache permissions. Artifact expiry uses a Before run prepared at least a day earlier, because real expiration cannot happen within this session. Reporting and runner readiness finish the technical content. At minute forty-five we stop starting new demonstrations and use the remaining five minutes for adoption actions and buffer. Q&amp;A starts at minute fifty. If runners are queued or administrator access is unavailable, I will say so and show an identified rehearsal run instead of pretending the live demo succeeded.</a:t>
             </a:r>
           </a:p>
         </p:txBody>
@@ -1702,7 +1702,7 @@
           <a:lstStyle/>
           <a:p>
             <a:r>
-              <a:t>This appendix contains clickable first-party release sources for the five selected updates. The publication window is September tenth through October ninth, inclusive. The complete catalog contains twelve verified Actions-related entries, including other features and operational notices that were not selected. No Actions-tagged entry later than October second was present in the official feeds when researched. Recheck the official changelog before delivery if you want to add releases after the research cutoff, but do not silently change the promised thirty-day window or selected topic scope.</a:t>
+              <a:t>This appendix contains the first-party release links for the five selected topics. The research window is September tenth through October ninth, inclusive. Publication date is not the same as universally verified account availability. The Before workflows describe older approaches or establish an original artifact state; they run on today's GitHub service and are not a time machine for retired behavior. The deck's speaker notes contain the run instructions and prerequisites so the simplified repository needs only the presentation and ten workflow files. Recheck account capabilities and the official documentation at rehearsal. If a feature is unavailable or a live run has not completed, state that limitation and distinguish any previously captured evidence from the live attempt.</a:t>
             </a:r>
           </a:p>
         </p:txBody>
@@ -1772,7 +1772,7 @@
           <a:lstStyle/>
           <a:p>
             <a:r>
-              <a:t>These references support implementation and interpretation. The runner deprecation endpoint came from the earlier September third update, so it is outside the selected research window and should be described as supporting prior functionality. Workflow syntax explains that forbidden cache operations can continue without failing the job, which is why the demo independently verifies cache state. Policy documentation explains the separate actor/event rules, layered enforcement, and Enterprise Cloud evaluate mode. The workflow-run REST documentation distinguishes the filtered retrieval cap from the count-reporting announcement. Use the exact account capabilities and live response schema at rehearsal rather than assuming all cloud behavior is available on Enterprise Server.</a:t>
+              <a:t>These implementation references explain the configuration and API details used in the small workflow pairs. Cache-mode documentation describes why a forbidden save can remain a green step. Policy documentation explains central event allowlists, exact file targeting, and the account capability needed for evaluate mode and insights. Artifact APIs support comparing the retained receipt with the later absent record. Workflow-run documentation describes the separate filtered retrieval cap. The runner deprecation API was announced September third, before our selected thirty-day window, and is supporting prior functionality for the September twenty-eighth enforcement notice. Its two dates should be inspected independently. Do not infer Enterprise Server support or administrator privilege from a cloud announcement.</a:t>
             </a:r>
           </a:p>
         </p:txBody>
@@ -1842,7 +1842,7 @@
           <a:lstStyle/>
           <a:p>
             <a:r>
-              <a:t>Use this appendix as the pre-delivery gate. The package must be committed to the destination repository's default branch, including the hidden dot-github folder. Actions and the pinned first-party actions must be permitted by the account. Administrative credentials belong in the protected demo-admin environment and should be scoped to the disposable repository. Evaluate requires Enterprise Cloud; active mode can be used only in the approved isolated target if evaluate is unavailable. Seed the artifact early enough for the real expiration and asynchronous cleanup, record the exact expiry and seed run ID, and rehearse inspection before delivery. The local preparation did not publish a repository or execute GitHub service behavior on the presenter's behalf. That remaining rehearsal is necessary before calling any live demo verified.</a:t>
+              <a:t>The private repository is seandorsett/dxc-actions-office-hour. Its current tree contains only the deck and the ten workflow files under dot-github slash workflows. The build source and original template have been preserved outside the repository, and prior versions remain in Git history. To run a pair, open Actions, choose its numbered Before workflow, and then its After workflow. Every file contains its own instructions and prerequisites. Demos one, three, and four use the normal scoped Actions token where needed. Demo two requires a repository administrator to configure the named file-scoped policy in Settings. Demo five requires the approved read credential in demo-admin; restrict that environment to the default branch and use required reviewers where your plan permits them. Seed Demo 3 BEFORE at least a day early and record its actual expiry. Rehearse before delivery; these workflow files have not been represented as successful live runs merely because they parse locally. Keep the DXC Internal deck in this private repository.</a:t>
             </a:r>
           </a:p>
         </p:txBody>
@@ -1912,7 +1912,7 @@
           <a:lstStyle/>
           <a:p>
             <a:r>
-              <a:t>After the session, remove the specific demo policy using its recorded ID. The script refuses a policy with an unrelated name prefix or workflow target, but the presenter should still review the selected ID. Revoke short-lived administrative credentials and remove environment secrets that are no longer needed. Demo caches may be removed only by their exact run-specific prefix, not with a broad delete-all operation. The expiry target must not be manually deleted before the observation because that would undermine the natural-expiry demonstration. Receipts and report artifacts have their own retention and account caps still apply. No runner audit cleanup requires stopping or deleting runners because the audit is read-only. The template carries DXC Internal branding and fleet reports may contain internal metadata, so retain them only in an appropriately restricted repository.</a:t>
+              <a:t>Cleanup should be as small as the examples. In Settings, Actions, Policies, delete only the policy named dxc-office-hour-demo-2 and confirm it targeted only demo-2-after dot yml. Do not remove an inherited or production policy. Revoke the temporary RUNNER_READ_TOKEN when no longer needed and remove its environment secret. Demo cache keys start with dxc-oh-simple and include the specific run ID; optionally remove only those entries through the cache UI. The one-day artifact must expire naturally for the comparison to be meaningful, so do not delete it before observing After. Its fourteen-day receipt is also subject to account retention caps and eventually expires. Reporting and runner-date lookups do not change remote records or fleets. None of these demonstrations deploys to production. Keep the deck and any run metadata appropriately restricted because the supplied template retains DXC Internal branding.</a:t>
             </a:r>
           </a:p>
         </p:txBody>
@@ -2052,7 +2052,7 @@
           <a:lstStyle/>
           <a:p>
             <a:r>
-              <a:t>Read means restore only. Write permits both restore and save. Write-only permits publishing without restoring existing content. None disables both operations. These are access modes, not cache hit guarantees: an allowed restore can still miss because the key does not exist. Also, when the effective mode denies an operation, the cache step can log an informational message and continue without failing the job. A denied restore behaves like a miss and a denied save simply does not happen. That is why a green Actions step is not sufficient verification. Our workflow first seeds known content, checks whether the marker really appeared, and then uses a separate API-based verifier to determine whether candidate cache entries were actually created. This turns the abstract permission matrix into directly inspectable results.</a:t>
+              <a:t>Read permits restores but not saves. Write permits both. Write-only permits saves without restores, and none permits neither. This table explains all four modes, but our live comparison deliberately demonstrates only the straightforward change from implicit trusted-trigger access to explicit read-only access. The Before workflow saves a harmless text file using its manual trigger's default cache access. The After workflow restores that known text, attempts a new save under cache-mode read, and checks that the candidate key is absent from the cache inventory. Forbidden cache operations can log and continue, so a green save step does not prove a save occurred. We will inspect both the restored content and the actual inventory result. There are no reusable helpers, matrices, package installations, or customer data in this simplified demo.</a:t>
             </a:r>
           </a:p>
         </p:txBody>
@@ -2122,7 +2122,7 @@
           <a:lstStyle/>
           <a:p>
             <a:r>
-              <a:t>This is the part I want platform teams to notice. A repository can call a reusable workflow while limiting the cache access granted to it. In this example the caller grants read. The called workflow requests write, but that declaration cannot increase access above what the caller allowed. In our package, the same reusable helper is called four times with the four different modes. This makes the trust ceiling easy to see without duplicating four different implementations. We expect the read caller to restore the trusted seed while failing to publish its candidate cache. The service-side cache inventory is the final evidence for that second claim. When adopting this pattern, document both the reusable workflow's requirements and the caller's trust assumptions so that the limit is intentional rather than an unexplained cache miss.</a:t>
+              <a:t>Here is the central change, kept small enough to explain without a platform framework. Both examples are manually dispatched on a hosted Ubuntu runner. The Before file does not declare cache-mode, so GitHub applies the trusted event's default access. It saves a text file containing the words trusted sample. The After file explicitly declares cache-mode read. It uses the successful Before run ID to restore the same known cache, then tries to save a different candidate key. The new setting denies that save. This is a comparison of workflow configuration on the current service, not a recreation of an older GitHub runtime. Cache permissions also constrain reusable workflows, but we are not adding a reusable-workflow demo here. The complete small YAML files are in the repository.</a:t>
             </a:r>
           </a:p>
         </p:txBody>
@@ -2192,7 +2192,7 @@
           <a:lstStyle/>
           <a:p>
             <a:r>
-              <a:t>Switch to the GitHub demo repository. Open the cache-mode workflow and its reusable helper, then launch the workflow on the default branch, or open the already-running rehearsal if queue time is significant. Explain the trusted seed and unique run-specific keys. Open each probe summary to show the asserted restore outcome. Then open the verifier summary, which checks actual cache records through the API. The two save-capable modes should have candidate entries and the two other modes should not. The called helper requested write throughout, demonstrating the caller ceiling at the same time. If a result does not match, say that the observed behavior is unresolved and inspect the actual logs; do not call it successful because all cache steps are green. Keep this segment to five minutes. If the live run is queued, show a real successful rehearsal run with its timestamp and transition. We have controlled what a running job may do with cache content; next we control whether a workflow may execute.</a:t>
+              <a:t>Open the Actions tab in seandorsett/dxc-actions-office-hour. Select Demo 1 BEFORE, click Run workflow, and use the default branch. Say: The old approach lets this trusted event use its default cache capability. Open the completed summary and copy the Before run ID. Next select Demo 1 AFTER and paste that number into before_run_id. Say: We have now made the cache access explicit and limited it to read. Open the restored-content step, the attempted-save step, and the final summary. The text should restore, while the new candidate key should not appear in inventory. If the marker is missing, check that Before succeeded and that you copied its run ID. If a key unexpectedly exists, inspect the actual service logs and do not call the result successful. Use a real rehearsal run if the queue is slow. Transition: Now we will control whether an entire workflow may run.</a:t>
             </a:r>
           </a:p>
         </p:txBody>
@@ -2332,7 +2332,7 @@
           <a:lstStyle/>
           <a:p>
             <a:r>
-              <a:t>This excerpt shows the core policy body used by the demo. The management script supplies a unique demo name and scopes the policy to one exact file. That file has two harmless triggers: manual workflow dispatch and a specifically named repository dispatch. The policy permits only the first. The control workflow is not targeted, so we retain a recovery and cleanup path. In a real deployment, actor rules can be layered with event rules, but we are deliberately keeping the live example small and observable. Policy writes use an approved administrator credential stored in a protected Actions environment. The ordinary GITHUB_TOKEN should not be assumed to have these administrative privileges. If our account lacks evaluate mode, we can use active mode directly in the disposable repository and explain the missing evaluate capability honestly.</a:t>
+              <a:t>The feature is a central GitHub Actions execution policy. It is not implemented by a shell test inside a workflow. To keep the demo simple, a repository administrator creates this policy using Settings, Actions, Policies. Name it dxc-office-hour-demo-2, target only dot-github slash workflows slash demo-2-after dot yml, choose Active enforcement, and allow push but not workflow_dispatch. The After file has only a manual trigger, so that trigger should be blocked before its job starts. The Before file is outside this demo policy and can still run if inherited policies permit it. The JSON on the slide shows the equivalent policy shape, not a separate script we need to execute. Evaluate and policy insights require the appropriate Enterprise Cloud capability. If these settings are unavailable, explain the limitation rather than pretending a workflow's own exit code proves central policy enforcement.</a:t>
             </a:r>
           </a:p>
         </p:txBody>
@@ -2402,7 +2402,7 @@
           <a:lstStyle/>
           <a:p>
             <a:r>
-              <a:t>Switch to the policy-control workflow. Start with inspect to show that inherited policies remain visible. Create the demo policy in evaluate mode if supported, otherwise use the already-approved active-mode path. Record the returned policy ID. Submit the allowed and disallowed probes and find the generated labels in the harmless target workflow. In evaluate mode, the disallowed event may still execute while insights record the would-block result. Activate the policy with its ID and repeat the probes. Show the actual policy error for the repository-dispatch attempt and the successful permitted manual execution. Do not treat an HTTP acceptance response as proof of enforcement; dispatch is asynchronous and the actual target result matters. Run cleanup using the recorded ID. If credentials, plan entitlement, or an inherited policy prevent this demo, state the blocker and show real rehearsal evidence or the configuration without simulating success. Finish by noting that no production or organization-wide policy was weakened.</a:t>
+              <a:t>Open Demo 2 BEFORE and run it manually. Say: This harmless job reached a runner, and it performs no deployment. Then open the repository's Settings, Actions, Policies. Create the policy described on the previous slide if it was not already prepared. Confirm the exact After workflow path and Active enforcement; do not target all workflows. Return to Actions and manually trigger Demo 2 AFTER. Say: The policy should stop this dispatch before a job reaches a runner. Show the actual GitHub policy error, or policy insights if the account supports them. The After YAML contains a deliberately failing diagnostic step only for the case where the policy is absent, in evaluate mode, or not applicable. That script failure is not the feature evidence; an actual pre-job policy block is. If the UI capability or administrator access is unavailable, use clearly identified rehearsal evidence. After showing the result, delete only dxc-office-hour-demo-2 from the Policies settings. Transition: Execution is protected, but evidence still has a lifecycle.</a:t>
             </a:r>
           </a:p>
         </p:txBody>
@@ -19022,7 +19022,7 @@
                 </a:solidFill>
                 <a:latin typeface="Arial"/>
               </a:rPr>
-              <a:t>7 | One-day artifact; fourteen-day receipt</a:t>
+              <a:t>7 | Two simple workflows separated by real elapsed time</a:t>
             </a:r>
           </a:p>
         </p:txBody>
@@ -19401,7 +19401,7 @@
                 </a:solidFill>
                 <a:latin typeface="Arial"/>
               </a:rPr>
-              <a:t>Seed</a:t>
+              <a:t>Before</a:t>
             </a:r>
           </a:p>
         </p:txBody>
@@ -19440,7 +19440,7 @@
                 </a:solidFill>
                 <a:latin typeface="Arial"/>
               </a:rPr>
-              <a:t>Upload harmless content</a:t>
+              <a:t>Upload one-day artifact</a:t>
             </a:r>
           </a:p>
           <a:p>
@@ -19456,7 +19456,7 @@
                 </a:solidFill>
                 <a:latin typeface="Arial"/>
               </a:rPr>
-              <a:t>before the session.</a:t>
+              <a:t>and retain its receipt.</a:t>
             </a:r>
           </a:p>
         </p:txBody>
@@ -19495,7 +19495,7 @@
                 </a:solidFill>
                 <a:latin typeface="Arial"/>
               </a:rPr>
-              <a:t>Receipt</a:t>
+              <a:t>Record</a:t>
             </a:r>
           </a:p>
         </p:txBody>
@@ -19534,7 +19534,7 @@
                 </a:solidFill>
                 <a:latin typeface="Arial"/>
               </a:rPr>
-              <a:t>Record actual ID,</a:t>
+              <a:t>Copy the Before run ID</a:t>
             </a:r>
           </a:p>
           <a:p>
@@ -19550,7 +19550,7 @@
                 </a:solidFill>
                 <a:latin typeface="Arial"/>
               </a:rPr>
-              <a:t>created_at, expires_at.</a:t>
+              <a:t>and actual expires_at.</a:t>
             </a:r>
           </a:p>
         </p:txBody>
@@ -19683,7 +19683,7 @@
                 </a:solidFill>
                 <a:latin typeface="Arial"/>
               </a:rPr>
-              <a:t>Observe</a:t>
+              <a:t>After</a:t>
             </a:r>
           </a:p>
         </p:txBody>
@@ -19722,7 +19722,7 @@
                 </a:solidFill>
                 <a:latin typeface="Arial"/>
               </a:rPr>
-              <a:t>Check list absence</a:t>
+              <a:t>List is empty;</a:t>
             </a:r>
           </a:p>
           <a:p>
@@ -19738,7 +19738,7 @@
                 </a:solidFill>
                 <a:latin typeface="Arial"/>
               </a:rPr>
-              <a:t>and direct GET 404.</a:t>
+              <a:t>direct GET returns 404.</a:t>
             </a:r>
           </a:p>
         </p:txBody>
@@ -19971,7 +19971,7 @@
                 </a:solidFill>
                 <a:latin typeface="Arial"/>
               </a:rPr>
-              <a:t>Demo 3 | Inspect an earlier seeded artifact</a:t>
+              <a:t>Demo 3 | Before exists; After is absent</a:t>
             </a:r>
           </a:p>
         </p:txBody>
@@ -20013,7 +20013,7 @@
                 </a:solidFill>
                 <a:latin typeface="Consolas"/>
               </a:rPr>
-              <a:t>demo-3-artifact-expiry.yml</a:t>
+              <a:t>demo-3-before.yml  /  demo-3-after.yml</a:t>
             </a:r>
           </a:p>
         </p:txBody>
@@ -20095,7 +20095,7 @@
                 </a:solidFill>
                 <a:latin typeface="Arial"/>
               </a:rPr>
-              <a:t>1. Open seed evidence</a:t>
+              <a:t>1. Before session</a:t>
             </a:r>
           </a:p>
         </p:txBody>
@@ -20134,7 +20134,7 @@
                 </a:solidFill>
                 <a:latin typeface="Arial"/>
               </a:rPr>
-              <a:t>Show the successful earlier seed run and retained receipt.</a:t>
+              <a:t>Run Before at least a day early. Keep its successful run ID.</a:t>
             </a:r>
           </a:p>
         </p:txBody>
@@ -20216,7 +20216,7 @@
                 </a:solidFill>
                 <a:latin typeface="Arial"/>
               </a:rPr>
-              <a:t>2. Inspect</a:t>
+              <a:t>2. After expiry</a:t>
             </a:r>
           </a:p>
         </p:txBody>
@@ -20255,7 +20255,7 @@
                 </a:solidFill>
                 <a:latin typeface="Arial"/>
               </a:rPr>
-              <a:t>operation=inspect; enter the recorded seed run ID.</a:t>
+              <a:t>Run After with that before_run_id once expires_at has passed.</a:t>
             </a:r>
           </a:p>
         </p:txBody>
@@ -20376,7 +20376,7 @@
                 </a:solidFill>
                 <a:latin typeface="Arial"/>
               </a:rPr>
-              <a:t>List absence + direct GET 404 + original expiry and upload logs.</a:t>
+              <a:t>Original receipt and upload log vs empty list and direct GET 404.</a:t>
             </a:r>
           </a:p>
         </p:txBody>
@@ -20603,7 +20603,7 @@
                 </a:solidFill>
                 <a:latin typeface="Arial"/>
               </a:rPr>
-              <a:t>If the seed is too recent or cleanup is pending, say NOT READY and use genuine rehearsal evidence.</a:t>
+              <a:t>Do not delete the target. A fresh Before run cannot demonstrate natural expiry immediately.</a:t>
             </a:r>
           </a:p>
         </p:txBody>
@@ -21252,7 +21252,7 @@
                 </a:solidFill>
                 <a:latin typeface="Arial"/>
               </a:rPr>
-              <a:t>8 | Explicit UTC bounds; distinct run IDs; bounded requests</a:t>
+              <a:t>8 | One UTC day; real API results; explicit saturation guard</a:t>
             </a:r>
           </a:p>
         </p:txBody>
@@ -21291,7 +21291,7 @@
                 </a:solidFill>
                 <a:latin typeface="Arial"/>
               </a:rPr>
-              <a:t>Split the time window before you hit the retrieval cap</a:t>
+              <a:t>Keep reporting simple: choose a day, then follow pages</a:t>
             </a:r>
           </a:p>
         </p:txBody>
@@ -21631,7 +21631,7 @@
                 </a:solidFill>
                 <a:latin typeface="Arial"/>
               </a:rPr>
-              <a:t>Query</a:t>
+              <a:t>Before</a:t>
             </a:r>
           </a:p>
         </p:txBody>
@@ -21670,7 +21670,7 @@
                 </a:solidFill>
                 <a:latin typeface="Arial"/>
               </a:rPr>
-              <a:t>Read count and first page</a:t>
+              <a:t>Broad query;</a:t>
             </a:r>
           </a:p>
           <a:p>
@@ -21686,7 +21686,7 @@
                 </a:solidFill>
                 <a:latin typeface="Arial"/>
               </a:rPr>
-              <a:t>for an explicit window.</a:t>
+              <a:t>only the first two runs.</a:t>
             </a:r>
           </a:p>
         </p:txBody>
@@ -21725,7 +21725,7 @@
                 </a:solidFill>
                 <a:latin typeface="Arial"/>
               </a:rPr>
-              <a:t>Split</a:t>
+              <a:t>Bound</a:t>
             </a:r>
           </a:p>
         </p:txBody>
@@ -21764,7 +21764,7 @@
                 </a:solidFill>
                 <a:latin typeface="Arial"/>
               </a:rPr>
-              <a:t>If bounded or &gt;=1,000,</a:t>
+              <a:t>Choose a UTC day</a:t>
             </a:r>
           </a:p>
           <a:p>
@@ -21780,7 +21780,7 @@
                 </a:solidFill>
                 <a:latin typeface="Arial"/>
               </a:rPr>
-              <a:t>subdivide into adjacent windows.</a:t>
+              <a:t>containing rehearsal runs.</a:t>
             </a:r>
           </a:p>
         </p:txBody>
@@ -21819,7 +21819,7 @@
                 </a:solidFill>
                 <a:latin typeface="Arial"/>
               </a:rPr>
-              <a:t>Enumerate</a:t>
+              <a:t>Guard</a:t>
             </a:r>
           </a:p>
         </p:txBody>
@@ -21858,7 +21858,7 @@
                 </a:solidFill>
                 <a:latin typeface="Arial"/>
               </a:rPr>
-              <a:t>Page smaller windows;</a:t>
+              <a:t>If count reaches 1,000,</a:t>
             </a:r>
           </a:p>
           <a:p>
@@ -21874,7 +21874,7 @@
                 </a:solidFill>
                 <a:latin typeface="Arial"/>
               </a:rPr>
-              <a:t>deduplicate run IDs.</a:t>
+              <a:t>stop and narrow further.</a:t>
             </a:r>
           </a:p>
         </p:txBody>
@@ -21913,7 +21913,7 @@
                 </a:solidFill>
                 <a:latin typeface="Arial"/>
               </a:rPr>
-              <a:t>Stop safely</a:t>
+              <a:t>After</a:t>
             </a:r>
           </a:p>
         </p:txBody>
@@ -21952,7 +21952,7 @@
                 </a:solidFill>
                 <a:latin typeface="Arial"/>
               </a:rPr>
-              <a:t>Fail on saturation or budget;</a:t>
+              <a:t>Follow pages;</a:t>
             </a:r>
           </a:p>
           <a:p>
@@ -21968,7 +21968,7 @@
                 </a:solidFill>
                 <a:latin typeface="Arial"/>
               </a:rPr>
-              <a:t>never claim truncated data is complete.</a:t>
+              <a:t>show distinct run IDs.</a:t>
             </a:r>
           </a:p>
         </p:txBody>
@@ -22201,7 +22201,7 @@
                 </a:solidFill>
                 <a:latin typeface="Arial"/>
               </a:rPr>
-              <a:t>Demo 4 | Live small-repo pagination; labeled large-count fixture</a:t>
+              <a:t>Demo 4 | One broad page vs date-bounded pages</a:t>
             </a:r>
           </a:p>
         </p:txBody>
@@ -22243,7 +22243,7 @@
                 </a:solidFill>
                 <a:latin typeface="Consolas"/>
               </a:rPr>
-              <a:t>demo-4-bounded-reporting.yml</a:t>
+              <a:t>demo-4-before.yml  /  demo-4-after.yml</a:t>
             </a:r>
           </a:p>
         </p:txBody>
@@ -22325,7 +22325,7 @@
                 </a:solidFill>
                 <a:latin typeface="Arial"/>
               </a:rPr>
-              <a:t>1. Live query</a:t>
+              <a:t>1. Before</a:t>
             </a:r>
           </a:p>
         </p:txBody>
@@ -22364,7 +22364,7 @@
                 </a:solidFill>
                 <a:latin typeface="Arial"/>
               </a:rPr>
-              <a:t>Dates cover rehearsal runs; page size 2 makes pagination visible.</a:t>
+              <a:t>Run the broad two-record query; inspect returned count vs records shown.</a:t>
             </a:r>
           </a:p>
         </p:txBody>
@@ -22446,7 +22446,7 @@
                 </a:solidFill>
                 <a:latin typeface="Arial"/>
               </a:rPr>
-              <a:t>2. Read evidence</a:t>
+              <a:t>2. After</a:t>
             </a:r>
           </a:p>
         </p:txBody>
@@ -22485,7 +22485,7 @@
                 </a:solidFill>
                 <a:latin typeface="Arial"/>
               </a:rPr>
-              <a:t>Inspect distinct IDs, actual counts, windows, and request total.</a:t>
+              <a:t>Choose the UTC day of rehearsal runs; follow all below-cap pages.</a:t>
             </a:r>
           </a:p>
         </p:txBody>
@@ -22567,7 +22567,7 @@
                 </a:solidFill>
                 <a:latin typeface="Arial"/>
               </a:rPr>
-              <a:t>3. Explain scale</a:t>
+              <a:t>3. Compare</a:t>
             </a:r>
           </a:p>
         </p:txBody>
@@ -22606,7 +22606,7 @@
                 </a:solidFill>
                 <a:latin typeface="Arial"/>
               </a:rPr>
-              <a:t>Show the synthetic bounded-count unit test; label it offline.</a:t>
+              <a:t>Actual run IDs and query scope, not an invented large-volume result.</a:t>
             </a:r>
           </a:p>
         </p:txBody>
@@ -22833,7 +22833,7 @@
                 </a:solidFill>
                 <a:latin typeface="Arial"/>
               </a:rPr>
-              <a:t>No large count observed = no live proof of the 2,500+ threshold.</a:t>
+              <a:t>Both workflows use today's API. No claim of live proof of the 2,500+ threshold.</a:t>
             </a:r>
           </a:p>
         </p:txBody>
@@ -23507,7 +23507,7 @@
                 </a:solidFill>
                 <a:latin typeface="Arial"/>
               </a:rPr>
-              <a:t>Demo 5 | Audit deadlines without disrupting a runner</a:t>
+              <a:t>Demo 5 | Registration-only check vs two live dates</a:t>
             </a:r>
           </a:p>
         </p:txBody>
@@ -23549,7 +23549,7 @@
                 </a:solidFill>
                 <a:latin typeface="Consolas"/>
               </a:rPr>
-              <a:t>demo-5-runner-readiness.yml</a:t>
+              <a:t>demo-5-before.yml  /  demo-5-after.yml</a:t>
             </a:r>
           </a:p>
         </p:txBody>
@@ -23631,7 +23631,7 @@
                 </a:solidFill>
                 <a:latin typeface="Arial"/>
               </a:rPr>
-              <a:t>1. Start read-only</a:t>
+              <a:t>1. Before</a:t>
             </a:r>
           </a:p>
         </p:txBody>
@@ -23670,7 +23670,7 @@
                 </a:solidFill>
                 <a:latin typeface="Arial"/>
               </a:rPr>
-              <a:t>Query explicit versions on a hosted runner; no fleet changes.</a:t>
+              <a:t>Compare 2.329.0 with the registration floor. Runtime remains unknown.</a:t>
             </a:r>
           </a:p>
         </p:txBody>
@@ -23752,7 +23752,7 @@
                 </a:solidFill>
                 <a:latin typeface="Arial"/>
               </a:rPr>
-              <a:t>2. Compare dates</a:t>
+              <a:t>2. After</a:t>
             </a:r>
           </a:p>
         </p:txBody>
@@ -23791,7 +23791,7 @@
                 </a:solidFill>
                 <a:latin typeface="Arial"/>
               </a:rPr>
-              <a:t>Show registration and runtime deprecation independently.</a:t>
+              <a:t>Query GitHub for registration_deprecates_at and runtime_deprecates_at.</a:t>
             </a:r>
           </a:p>
         </p:txBody>
@@ -23873,7 +23873,7 @@
                 </a:solidFill>
                 <a:latin typeface="Arial"/>
               </a:rPr>
-              <a:t>3. Optional inventory</a:t>
+              <a:t>3. Compare</a:t>
             </a:r>
           </a:p>
         </p:txBody>
@@ -23912,7 +23912,7 @@
                 </a:solidFill>
                 <a:latin typeface="Arial"/>
               </a:rPr>
-              <a:t>Add approved fleet versions; missing versions remain unknown.</a:t>
+              <a:t>Treat a missing date as unknown, not a support guarantee.</a:t>
             </a:r>
           </a:p>
         </p:txBody>
@@ -24139,7 +24139,7 @@
                 </a:solidFill>
                 <a:latin typeface="Arial"/>
               </a:rPr>
-              <a:t>No date returned is not a guarantee of support. Never downgrade a runner for this demo.</a:t>
+              <a:t>After needs an approved RUNNER_READ_TOKEN. No runner is registered, stopped, or changed.</a:t>
             </a:r>
           </a:p>
         </p:txBody>
@@ -24440,7 +24440,7 @@
                           </a:solidFill>
                           <a:latin typeface="Arial"/>
                         </a:rPr>
-                        <a:t>Assign cache modes by trust boundary</a:t>
+                        <a:t>Choose explicit cache access by trust boundary</a:t>
                       </a:r>
                     </a:p>
                   </a:txBody>
@@ -24469,7 +24469,7 @@
                           </a:solidFill>
                           <a:latin typeface="Arial"/>
                         </a:rPr>
-                        <a:t>Restore/save assertions and cache inventory</a:t>
+                        <a:t>Before save vs After restore-only result</a:t>
                       </a:r>
                     </a:p>
                   </a:txBody>
@@ -24529,7 +24529,7 @@
                           </a:solidFill>
                           <a:latin typeface="Arial"/>
                         </a:rPr>
-                        <a:t>Pilot file-scoped execution protections</a:t>
+                        <a:t>Pilot a narrowly targeted execution policy</a:t>
                       </a:r>
                     </a:p>
                   </a:txBody>
@@ -24558,7 +24558,7 @@
                           </a:solidFill>
                           <a:latin typeface="Arial"/>
                         </a:rPr>
-                        <a:t>Evaluate insights, then actual enforcement</a:t>
+                        <a:t>Actual pre-job block for the After file</a:t>
                       </a:r>
                     </a:p>
                   </a:txBody>
@@ -24647,7 +24647,7 @@
                           </a:solidFill>
                           <a:latin typeface="Arial"/>
                         </a:rPr>
-                        <a:t>Original receipt and retained upload logs</a:t>
+                        <a:t>Before receipt vs After API absence</a:t>
                       </a:r>
                     </a:p>
                   </a:txBody>
@@ -24707,7 +24707,7 @@
                           </a:solidFill>
                           <a:latin typeface="Arial"/>
                         </a:rPr>
-                        <a:t>Bound queries and paginate smaller windows</a:t>
+                        <a:t>Bound time windows and follow pages</a:t>
                       </a:r>
                     </a:p>
                   </a:txBody>
@@ -24736,7 +24736,7 @@
                           </a:solidFill>
                           <a:latin typeface="Arial"/>
                         </a:rPr>
-                        <a:t>Actual counts, IDs, and completeness caveats</a:t>
+                        <a:t>Actual returned IDs and cap guard</a:t>
                       </a:r>
                     </a:p>
                   </a:txBody>
@@ -24796,7 +24796,7 @@
                           </a:solidFill>
                           <a:latin typeface="Arial"/>
                         </a:rPr>
-                        <a:t>Check registration AND runtime readiness</a:t>
+                        <a:t>Check registration AND runtime dates</a:t>
                       </a:r>
                     </a:p>
                   </a:txBody>
@@ -24825,7 +24825,7 @@
                           </a:solidFill>
                           <a:latin typeface="Arial"/>
                         </a:rPr>
-                        <a:t>Live deprecation dates and fleet versions</a:t>
+                        <a:t>Local assumption vs live API dates</a:t>
                       </a:r>
                     </a:p>
                   </a:txBody>
@@ -25149,7 +25149,7 @@
                 </a:solidFill>
                 <a:latin typeface="Arial"/>
               </a:rPr>
-              <a:t>Limit cache capability.</a:t>
+              <a:t>Choose explicit cache access.</a:t>
             </a:r>
           </a:p>
           <a:p>
@@ -25165,7 +25165,7 @@
                 </a:solidFill>
                 <a:latin typeface="Arial"/>
               </a:rPr>
-              <a:t>Scope workflow execution policy.</a:t>
+              <a:t>Scope policy to one workflow.</a:t>
             </a:r>
           </a:p>
           <a:p>
@@ -25302,7 +25302,7 @@
                 </a:solidFill>
                 <a:latin typeface="Arial"/>
               </a:rPr>
-              <a:t>Observe actual service outcomes.</a:t>
+              <a:t>Compare real Before and After results.</a:t>
             </a:r>
           </a:p>
           <a:p>
@@ -25334,7 +25334,7 @@
                 </a:solidFill>
                 <a:latin typeface="Arial"/>
               </a:rPr>
-              <a:t>Distinguish live results from fixtures.</a:t>
+              <a:t>Keep assumptions separate from evidence.</a:t>
             </a:r>
           </a:p>
         </p:txBody>
@@ -25455,7 +25455,7 @@
                 </a:solidFill>
                 <a:latin typeface="Arial"/>
               </a:rPr>
-              <a:t>Seed time-based demos early.</a:t>
+              <a:t>Seed the expiry example early.</a:t>
             </a:r>
           </a:p>
           <a:p>
@@ -25471,7 +25471,7 @@
                 </a:solidFill>
                 <a:latin typeface="Arial"/>
               </a:rPr>
-              <a:t>Audit runner dates independently.</a:t>
+              <a:t>Check the two runner dates.</a:t>
             </a:r>
           </a:p>
           <a:p>
@@ -25487,7 +25487,7 @@
                 </a:solidFill>
                 <a:latin typeface="Arial"/>
               </a:rPr>
-              <a:t>Keep rollback and cleanup explicit.</a:t>
+              <a:t>Keep setup and cleanup explicit.</a:t>
             </a:r>
           </a:p>
         </p:txBody>
@@ -25875,7 +25875,7 @@
                           </a:solidFill>
                           <a:latin typeface="Arial"/>
                         </a:rPr>
-                        <a:t>Four modes; reusable-workflow ceiling</a:t>
+                        <a:t>Implicit write access vs explicit read-only</a:t>
                       </a:r>
                     </a:p>
                   </a:txBody>
@@ -25964,7 +25964,7 @@
                           </a:solidFill>
                           <a:latin typeface="Arial"/>
                         </a:rPr>
-                        <a:t>File-scoped policy and real trigger outcomes</a:t>
+                        <a:t>Before runs; file-scoped policy blocks After</a:t>
                       </a:r>
                     </a:p>
                   </a:txBody>
@@ -26053,7 +26053,7 @@
                           </a:solidFill>
                           <a:latin typeface="Arial"/>
                         </a:rPr>
-                        <a:t>Natural expiry with retained provenance</a:t>
+                        <a:t>Artifact exists, then disappears after expiry</a:t>
                       </a:r>
                     </a:p>
                   </a:txBody>
@@ -26142,7 +26142,7 @@
                           </a:solidFill>
                           <a:latin typeface="Arial"/>
                         </a:rPr>
-                        <a:t>Counts, retrieval caps, and time windows</a:t>
+                        <a:t>One broad page vs date-bounded pagination</a:t>
                       </a:r>
                     </a:p>
                   </a:txBody>
@@ -26231,7 +26231,7 @@
                           </a:solidFill>
                           <a:latin typeface="Arial"/>
                         </a:rPr>
-                        <a:t>Registration is not runtime support</a:t>
+                        <a:t>Registration-only assumption vs two live dates</a:t>
                       </a:r>
                     </a:p>
                   </a:txBody>
@@ -26320,7 +26320,7 @@
                           </a:solidFill>
                           <a:latin typeface="Arial"/>
                         </a:rPr>
-                        <a:t>Owners, next actions, and buffer</a:t>
+                        <a:t>Next actions, takeaways, and buffer</a:t>
                       </a:r>
                     </a:p>
                   </a:txBody>
@@ -27399,7 +27399,7 @@
                 </a:solidFill>
                 <a:latin typeface="Arial"/>
               </a:rPr>
-              <a:t>Appendix | Local package is not a live GitHub rehearsal</a:t>
+              <a:t>Appendix | Setup and speaking cues are in this deck</a:t>
             </a:r>
           </a:p>
         </p:txBody>
@@ -27438,7 +27438,7 @@
                 </a:solidFill>
                 <a:latin typeface="Arial"/>
               </a:rPr>
-              <a:t>Rehearsal gate | What must be ready before delivery</a:t>
+              <a:t>Setup | Keep the simple comparisons ready</a:t>
             </a:r>
           </a:p>
         </p:txBody>
@@ -27559,7 +27559,7 @@
                 </a:solidFill>
                 <a:latin typeface="Arial"/>
               </a:rPr>
-              <a:t>Commit .github and scripts to the default branch.</a:t>
+              <a:t>Deck plus ten Before/After workflows.</a:t>
             </a:r>
           </a:p>
           <a:p>
@@ -27575,7 +27575,7 @@
                 </a:solidFill>
                 <a:latin typeface="Arial"/>
               </a:rPr>
-              <a:t>Enable pinned actions and hosted runners.</a:t>
+              <a:t>Actions tab &gt; Run workflow.</a:t>
             </a:r>
           </a:p>
           <a:p>
@@ -27591,7 +27591,7 @@
                 </a:solidFill>
                 <a:latin typeface="Arial"/>
               </a:rPr>
-              <a:t>Run package validation.</a:t>
+              <a:t>No helper scripts or package installs.</a:t>
             </a:r>
           </a:p>
         </p:txBody>
@@ -27673,7 +27673,7 @@
                 </a:solidFill>
                 <a:latin typeface="Arial"/>
               </a:rPr>
-              <a:t>Administrative access</a:t>
+              <a:t>Permissions</a:t>
             </a:r>
           </a:p>
         </p:txBody>
@@ -27712,7 +27712,7 @@
                 </a:solidFill>
                 <a:latin typeface="Arial"/>
               </a:rPr>
-              <a:t>Protect demo-admin and scope credentials.</a:t>
+              <a:t>Demo 2: administrator sets one policy.</a:t>
             </a:r>
           </a:p>
           <a:p>
@@ -27728,7 +27728,7 @@
                 </a:solidFill>
                 <a:latin typeface="Arial"/>
               </a:rPr>
-              <a:t>Confirm policy evaluate entitlement.</a:t>
+              <a:t>Demo 5: demo-admin + RUNNER_READ_TOKEN.</a:t>
             </a:r>
           </a:p>
           <a:p>
@@ -27744,7 +27744,7 @@
                 </a:solidFill>
                 <a:latin typeface="Arial"/>
               </a:rPr>
-              <a:t>Rehearse allowed/blocked outcomes.</a:t>
+              <a:t>Use the default branch for rehearsal.</a:t>
             </a:r>
           </a:p>
         </p:txBody>
@@ -27826,7 +27826,7 @@
                 </a:solidFill>
                 <a:latin typeface="Arial"/>
               </a:rPr>
-              <a:t>Time-based evidence</a:t>
+              <a:t>Preparation</a:t>
             </a:r>
           </a:p>
         </p:txBody>
@@ -27865,7 +27865,7 @@
                 </a:solidFill>
                 <a:latin typeface="Arial"/>
               </a:rPr>
-              <a:t>Seed artifact by 10-11 October if possible.</a:t>
+              <a:t>Demo 1: record the Before run ID.</a:t>
             </a:r>
           </a:p>
           <a:p>
@@ -27881,7 +27881,7 @@
                 </a:solidFill>
                 <a:latin typeface="Arial"/>
               </a:rPr>
-              <a:t>Record actual expires_at and seed ID.</a:t>
+              <a:t>Demo 3: seed at least a day early.</a:t>
             </a:r>
           </a:p>
           <a:p>
@@ -27897,7 +27897,7 @@
                 </a:solidFill>
                 <a:latin typeface="Arial"/>
               </a:rPr>
-              <a:t>Inspect after natural cleanup.</a:t>
+              <a:t>Demo 4: choose the rehearsal UTC day.</a:t>
             </a:r>
           </a:p>
         </p:txBody>
@@ -27955,7 +27955,7 @@
                 </a:solidFill>
                 <a:latin typeface="Arial"/>
               </a:rPr>
-              <a:t>No repository was published or live-tested during local preparation.</a:t>
+              <a:t>Open PowerPoint Presenter View to read the full speaking notes and demo instructions.</a:t>
             </a:r>
           </a:p>
         </p:txBody>
@@ -28211,7 +28211,7 @@
                 </a:solidFill>
                 <a:latin typeface="Arial"/>
               </a:rPr>
-              <a:t>Policy control: cleanup with recorded demo ID.</a:t>
+              <a:t>Delete only dxc-office-hour-demo-2 policy.</a:t>
             </a:r>
           </a:p>
           <a:p>
@@ -28227,7 +28227,7 @@
                 </a:solidFill>
                 <a:latin typeface="Arial"/>
               </a:rPr>
-              <a:t>Revoke temporary administrator credentials.</a:t>
+              <a:t>Revoke the temporary runner-read token.</a:t>
             </a:r>
           </a:p>
           <a:p>
@@ -28243,7 +28243,7 @@
                 </a:solidFill>
                 <a:latin typeface="Arial"/>
               </a:rPr>
-              <a:t>Optionally remove only run-specific demo caches.</a:t>
+              <a:t>Optionally remove specific demo cache keys.</a:t>
             </a:r>
           </a:p>
         </p:txBody>
@@ -28364,7 +28364,7 @@
                 </a:solidFill>
                 <a:latin typeface="Arial"/>
               </a:rPr>
-              <a:t>Do not delete the expiry target before observation.</a:t>
+              <a:t>Do not delete the expiry target early.</a:t>
             </a:r>
           </a:p>
           <a:p>
@@ -28380,7 +28380,7 @@
                 </a:solidFill>
                 <a:latin typeface="Arial"/>
               </a:rPr>
-              <a:t>Receipt artifacts last 14 days, reports 7 days.</a:t>
+              <a:t>Its receipt lasts 14 days, subject to caps.</a:t>
             </a:r>
           </a:p>
           <a:p>
@@ -28396,7 +28396,7 @@
                 </a:solidFill>
                 <a:latin typeface="Arial"/>
               </a:rPr>
-              <a:t>Runner audit never modifies a fleet.</a:t>
+              <a:t>Reporting and runner examples are read-only.</a:t>
             </a:r>
           </a:p>
         </p:txBody>
@@ -29972,7 +29972,7 @@
                 </a:solidFill>
                 <a:latin typeface="Arial"/>
               </a:rPr>
-              <a:t>1 | The caller sets the ceiling</a:t>
+              <a:t>1 | Same trusted manual trigger; different cache access</a:t>
             </a:r>
           </a:p>
         </p:txBody>
@@ -30011,7 +30011,7 @@
                 </a:solidFill>
                 <a:latin typeface="Arial"/>
               </a:rPr>
-              <a:t>A reusable workflow cannot elevate cache access</a:t>
+              <a:t>Before and after: one explicit cache access setting</a:t>
             </a:r>
           </a:p>
         </p:txBody>
@@ -30072,7 +30072,7 @@
                 </a:solidFill>
                 <a:latin typeface="Consolas"/>
               </a:rPr>
-              <a:t>jobs:</a:t>
+              <a:t># BEFORE: implicit trigger-based access</a:t>
             </a:r>
           </a:p>
           <a:p>
@@ -30091,7 +30091,7 @@
                 </a:solidFill>
                 <a:latin typeface="Consolas"/>
               </a:rPr>
-              <a:t>  read:</a:t>
+              <a:t>on: workflow_dispatch</a:t>
             </a:r>
           </a:p>
           <a:p>
@@ -30110,7 +30110,7 @@
                 </a:solidFill>
                 <a:latin typeface="Consolas"/>
               </a:rPr>
-              <a:t>    cache-mode: read</a:t>
+              <a:t># Trusted manual trigger may restore and save.</a:t>
             </a:r>
           </a:p>
           <a:p>
@@ -30129,7 +30129,7 @@
                 </a:solidFill>
                 <a:latin typeface="Consolas"/>
               </a:rPr>
-              <a:t>    uses: ./.github/workflows/demo-1-cache-probe.yml</a:t>
+              <a:t/>
             </a:r>
           </a:p>
           <a:p>
@@ -30148,7 +30148,7 @@
                 </a:solidFill>
                 <a:latin typeface="Consolas"/>
               </a:rPr>
-              <a:t>    with:</a:t>
+              <a:t># AFTER: choose the least access needed</a:t>
             </a:r>
           </a:p>
           <a:p>
@@ -30167,7 +30167,7 @@
                 </a:solidFill>
                 <a:latin typeface="Consolas"/>
               </a:rPr>
-              <a:t>      mode: read</a:t>
+              <a:t>on: workflow_dispatch</a:t>
             </a:r>
           </a:p>
           <a:p>
@@ -30186,7 +30186,7 @@
                 </a:solidFill>
                 <a:latin typeface="Consolas"/>
               </a:rPr>
-              <a:t/>
+              <a:t>cache-mode: read</a:t>
             </a:r>
           </a:p>
           <a:p>
@@ -30205,45 +30205,7 @@
                 </a:solidFill>
                 <a:latin typeface="Consolas"/>
               </a:rPr>
-              <a:t># Inside the called workflow:</a:t>
-            </a:r>
-          </a:p>
-          <a:p>
-            <a:pPr algn="l">
-              <a:lnSpc>
-                <a:spcPct val="110000"/>
-              </a:lnSpc>
-              <a:spcAft>
-                <a:spcPts val="0"/>
-              </a:spcAft>
-            </a:pPr>
-            <a:r>
-              <a:rPr sz="1500" b="0">
-                <a:solidFill>
-                  <a:srgbClr val="0E1022"/>
-                </a:solidFill>
-                <a:latin typeface="Consolas"/>
-              </a:rPr>
-              <a:t># cache-mode: write</a:t>
-            </a:r>
-          </a:p>
-          <a:p>
-            <a:pPr algn="l">
-              <a:lnSpc>
-                <a:spcPct val="110000"/>
-              </a:lnSpc>
-              <a:spcAft>
-                <a:spcPts val="0"/>
-              </a:spcAft>
-            </a:pPr>
-            <a:r>
-              <a:rPr sz="1500" b="0">
-                <a:solidFill>
-                  <a:srgbClr val="0E1022"/>
-                </a:solidFill>
-                <a:latin typeface="Consolas"/>
-              </a:rPr>
-              <a:t># Effective access still cannot exceed the caller.</a:t>
+              <a:t># Restore is allowed. A new save is denied.</a:t>
             </a:r>
           </a:p>
         </p:txBody>
@@ -30282,7 +30244,7 @@
                 </a:solidFill>
                 <a:latin typeface="Arial"/>
               </a:rPr>
-              <a:t>Caller</a:t>
+              <a:t>Before</a:t>
             </a:r>
           </a:p>
         </p:txBody>
@@ -30321,7 +30283,7 @@
                 </a:solidFill>
                 <a:latin typeface="Arial"/>
               </a:rPr>
-              <a:t>Grants read-only cache access.</a:t>
+              <a:t>Save a harmless text file using default access.</a:t>
             </a:r>
           </a:p>
         </p:txBody>
@@ -30360,7 +30322,7 @@
                 </a:solidFill>
                 <a:latin typeface="Arial"/>
               </a:rPr>
-              <a:t>Called workflow</a:t>
+              <a:t>After</a:t>
             </a:r>
           </a:p>
         </p:txBody>
@@ -30399,7 +30361,7 @@
                 </a:solidFill>
                 <a:latin typeface="Arial"/>
               </a:rPr>
-              <a:t>Requests write but cannot elevate.</a:t>
+              <a:t>Add cache-mode: read; restore the Before cache.</a:t>
             </a:r>
           </a:p>
         </p:txBody>
@@ -30438,7 +30400,7 @@
                 </a:solidFill>
                 <a:latin typeface="Arial"/>
               </a:rPr>
-              <a:t>Evidence</a:t>
+              <a:t>Visible result</a:t>
             </a:r>
           </a:p>
         </p:txBody>
@@ -30477,7 +30439,7 @@
                 </a:solidFill>
                 <a:latin typeface="Arial"/>
               </a:rPr>
-              <a:t>Restore succeeds; candidate save is absent.</a:t>
+              <a:t>Content restores, but the candidate save is absent.</a:t>
             </a:r>
           </a:p>
         </p:txBody>
@@ -30652,7 +30614,7 @@
                 </a:solidFill>
                 <a:latin typeface="Arial"/>
               </a:rPr>
-              <a:t>Demo 1 | Prove the permission matrix</a:t>
+              <a:t>Demo 1 | Implicit writes to explicit read-only</a:t>
             </a:r>
           </a:p>
         </p:txBody>
@@ -30694,7 +30656,7 @@
                 </a:solidFill>
                 <a:latin typeface="Consolas"/>
               </a:rPr>
-              <a:t>demo-1-cache-modes.yml</a:t>
+              <a:t>demo-1-before.yml  /  demo-1-after.yml</a:t>
             </a:r>
           </a:p>
         </p:txBody>
@@ -30776,7 +30738,7 @@
                 </a:solidFill>
                 <a:latin typeface="Arial"/>
               </a:rPr>
-              <a:t>1. Launch</a:t>
+              <a:t>1. Before</a:t>
             </a:r>
           </a:p>
         </p:txBody>
@@ -30815,7 +30777,7 @@
                 </a:solidFill>
                 <a:latin typeface="Arial"/>
               </a:rPr>
-              <a:t>Actions &gt; Demo 1 - Cache least privilege &gt; Run workflow</a:t>
+              <a:t>Run Demo 1 BEFORE. Copy its run ID from the summary.</a:t>
             </a:r>
           </a:p>
         </p:txBody>
@@ -30897,7 +30859,7 @@
                 </a:solidFill>
                 <a:latin typeface="Arial"/>
               </a:rPr>
-              <a:t>2. Observe restores</a:t>
+              <a:t>2. After</a:t>
             </a:r>
           </a:p>
         </p:txBody>
@@ -30936,7 +30898,7 @@
                 </a:solidFill>
                 <a:latin typeface="Arial"/>
               </a:rPr>
-              <a:t>Open the four reusable probe summaries and marker assertions.</a:t>
+              <a:t>Run Demo 1 AFTER with that before_run_id.</a:t>
             </a:r>
           </a:p>
         </p:txBody>
@@ -31018,7 +30980,7 @@
                 </a:solidFill>
                 <a:latin typeface="Arial"/>
               </a:rPr>
-              <a:t>3. Verify saves</a:t>
+              <a:t>3. Compare</a:t>
             </a:r>
           </a:p>
         </p:txBody>
@@ -31057,7 +31019,7 @@
                 </a:solidFill>
                 <a:latin typeface="Arial"/>
               </a:rPr>
-              <a:t>Open the independent cache-state verifier and evidence artifact.</a:t>
+              <a:t>Trusted text restored; candidate key absent; inspect the denied save step.</a:t>
             </a:r>
           </a:p>
         </p:txBody>
@@ -31284,7 +31246,7 @@
                 </a:solidFill>
                 <a:latin typeface="Arial"/>
               </a:rPr>
-              <a:t>Expected saves: write + write-only only. Expected restores: read + write only.</a:t>
+              <a:t>One new setting: cache-mode: read. No extra secrets or helper scripts.</a:t>
             </a:r>
           </a:p>
         </p:txBody>
@@ -32024,7 +31986,7 @@
                 </a:solidFill>
                 <a:latin typeface="Arial"/>
               </a:rPr>
-              <a:t>2 | This demo changes one disposable workflow only</a:t>
+              <a:t>2 | Policy is configured centrally, not by a YAML job</a:t>
             </a:r>
           </a:p>
         </p:txBody>
@@ -32063,7 +32025,7 @@
                 </a:solidFill>
                 <a:latin typeface="Arial"/>
               </a:rPr>
-              <a:t>Policy as code, with a deliberately narrow target</a:t>
+              <a:t>Before and after: policy targets one workflow file</a:t>
             </a:r>
           </a:p>
         </p:txBody>
@@ -32143,7 +32105,7 @@
                 </a:solidFill>
                 <a:latin typeface="Consolas"/>
               </a:rPr>
-              <a:t>  "enforcement": "evaluate",</a:t>
+              <a:t>  "name": "dxc-office-hour-demo-2",</a:t>
             </a:r>
           </a:p>
           <a:p>
@@ -32162,7 +32124,7 @@
                 </a:solidFill>
                 <a:latin typeface="Consolas"/>
               </a:rPr>
-              <a:t>  "conditions": {</a:t>
+              <a:t>  "enforcement": "active",</a:t>
             </a:r>
           </a:p>
           <a:p>
@@ -32181,7 +32143,7 @@
                 </a:solidFill>
                 <a:latin typeface="Consolas"/>
               </a:rPr>
-              <a:t>    "workflow_path": {</a:t>
+              <a:t>  "conditions": {"workflow_path": {</a:t>
             </a:r>
           </a:p>
           <a:p>
@@ -32200,7 +32162,7 @@
                 </a:solidFill>
                 <a:latin typeface="Consolas"/>
               </a:rPr>
-              <a:t>      "include": [".github/workflows/demo-2-policy-target.yml"],</a:t>
+              <a:t>    "include": [".github/workflows/demo-2-after.yml"],</a:t>
             </a:r>
           </a:p>
           <a:p>
@@ -32219,7 +32181,7 @@
                 </a:solidFill>
                 <a:latin typeface="Consolas"/>
               </a:rPr>
-              <a:t>      "exclude": []</a:t>
+              <a:t>    "exclude": []</a:t>
             </a:r>
           </a:p>
           <a:p>
@@ -32238,7 +32200,7 @@
                 </a:solidFill>
                 <a:latin typeface="Consolas"/>
               </a:rPr>
-              <a:t>    }</a:t>
+              <a:t>  }},</a:t>
             </a:r>
           </a:p>
           <a:p>
@@ -32257,7 +32219,7 @@
                 </a:solidFill>
                 <a:latin typeface="Consolas"/>
               </a:rPr>
-              <a:t>  },</a:t>
+              <a:t>  "rules": [{"type": "restrict_action_events",</a:t>
             </a:r>
           </a:p>
           <a:p>
@@ -32276,7 +32238,7 @@
                 </a:solidFill>
                 <a:latin typeface="Consolas"/>
               </a:rPr>
-              <a:t>  "rules": [{"type": "restrict_action_events",</a:t>
+              <a:t>    "parameters": {"allowed_events": ["push"]}}]</a:t>
             </a:r>
           </a:p>
           <a:p>
@@ -32295,25 +32257,6 @@
                 </a:solidFill>
                 <a:latin typeface="Consolas"/>
               </a:rPr>
-              <a:t>    "parameters": {"allowed_events": ["workflow_dispatch"]}}]</a:t>
-            </a:r>
-          </a:p>
-          <a:p>
-            <a:pPr algn="l">
-              <a:lnSpc>
-                <a:spcPct val="110000"/>
-              </a:lnSpc>
-              <a:spcAft>
-                <a:spcPts val="0"/>
-              </a:spcAft>
-            </a:pPr>
-            <a:r>
-              <a:rPr sz="1500" b="0">
-                <a:solidFill>
-                  <a:srgbClr val="0E1022"/>
-                </a:solidFill>
-                <a:latin typeface="Consolas"/>
-              </a:rPr>
               <a:t>}</a:t>
             </a:r>
           </a:p>
@@ -32353,7 +32296,7 @@
                 </a:solidFill>
                 <a:latin typeface="Arial"/>
               </a:rPr>
-              <a:t>Permitted</a:t>
+              <a:t>Before</a:t>
             </a:r>
           </a:p>
         </p:txBody>
@@ -32392,7 +32335,7 @@
                 </a:solidFill>
                 <a:latin typeface="Arial"/>
               </a:rPr>
-              <a:t>Manual workflow_dispatch.</a:t>
+              <a:t>Manual workflow is outside the demo policy.</a:t>
             </a:r>
           </a:p>
         </p:txBody>
@@ -32431,7 +32374,7 @@
                 </a:solidFill>
                 <a:latin typeface="Arial"/>
               </a:rPr>
-              <a:t>Disallowed</a:t>
+              <a:t>After</a:t>
             </a:r>
           </a:p>
         </p:txBody>
@@ -32470,7 +32413,7 @@
                 </a:solidFill>
                 <a:latin typeface="Arial"/>
               </a:rPr>
-              <a:t>Named repository_dispatch probe.</a:t>
+              <a:t>Manual trigger is disallowed for this exact path.</a:t>
             </a:r>
           </a:p>
         </p:txBody>
@@ -32509,7 +32452,7 @@
                 </a:solidFill>
                 <a:latin typeface="Arial"/>
               </a:rPr>
-              <a:t>Recovery path</a:t>
+              <a:t>Keep it simple</a:t>
             </a:r>
           </a:p>
         </p:txBody>
@@ -32548,7 +32491,7 @@
                 </a:solidFill>
                 <a:latin typeface="Arial"/>
               </a:rPr>
-              <a:t>Control workflow is outside the target.</a:t>
+              <a:t>Set policy in Settings &gt; Actions &gt; Policies.</a:t>
             </a:r>
           </a:p>
         </p:txBody>
@@ -32723,7 +32666,7 @@
                 </a:solidFill>
                 <a:latin typeface="Arial"/>
               </a:rPr>
-              <a:t>Demo 2 | Evaluate, enforce, inspect, then clean up</a:t>
+              <a:t>Demo 2 | Before runs; policy blocks After</a:t>
             </a:r>
           </a:p>
         </p:txBody>
@@ -32765,7 +32708,7 @@
                 </a:solidFill>
                 <a:latin typeface="Consolas"/>
               </a:rPr>
-              <a:t>demo-2-policy-control.yml</a:t>
+              <a:t>demo-2-before.yml  /  demo-2-after.yml</a:t>
             </a:r>
           </a:p>
         </p:txBody>
@@ -32847,7 +32790,7 @@
                 </a:solidFill>
                 <a:latin typeface="Arial"/>
               </a:rPr>
-              <a:t>1. Prepare</a:t>
+              <a:t>1. Before</a:t>
             </a:r>
           </a:p>
         </p:txBody>
@@ -32886,7 +32829,7 @@
                 </a:solidFill>
                 <a:latin typeface="Arial"/>
               </a:rPr>
-              <a:t>Inspect inherited policies; create-evaluate or create-active; record the ID.</a:t>
+              <a:t>Run the harmless Before workflow; observe its completed job.</a:t>
             </a:r>
           </a:p>
         </p:txBody>
@@ -32968,7 +32911,7 @@
                 </a:solidFill>
                 <a:latin typeface="Arial"/>
               </a:rPr>
-              <a:t>2. Probe</a:t>
+              <a:t>2. Set policy</a:t>
             </a:r>
           </a:p>
         </p:txBody>
@@ -33007,7 +32950,7 @@
                 </a:solidFill>
                 <a:latin typeface="Arial"/>
               </a:rPr>
-              <a:t>Send permitted manual dispatch and disallowed repository dispatch.</a:t>
+              <a:t>Target only demo-2-after.yml; Active; allow push, not manual dispatch.</a:t>
             </a:r>
           </a:p>
         </p:txBody>
@@ -33089,7 +33032,7 @@
                 </a:solidFill>
                 <a:latin typeface="Arial"/>
               </a:rPr>
-              <a:t>3. Enforce + recover</a:t>
+              <a:t>3. After</a:t>
             </a:r>
           </a:p>
         </p:txBody>
@@ -33128,7 +33071,7 @@
                 </a:solidFill>
                 <a:latin typeface="Arial"/>
               </a:rPr>
-              <a:t>Activate where needed; inspect actual error/insights; cleanup by ID.</a:t>
+              <a:t>Manually trigger After. Show the policy error before any job executes.</a:t>
             </a:r>
           </a:p>
         </p:txBody>
@@ -33355,7 +33298,7 @@
                 </a:solidFill>
                 <a:latin typeface="Arial"/>
               </a:rPr>
-              <a:t>HTTP acceptance proves request delivery, not workflow execution or policy enforcement.</a:t>
+              <a:t>If the After job reaches a runner, the intended policy did not block it.</a:t>
             </a:r>
           </a:p>
         </p:txBody>

</xml_diff>